<commit_message>
Switch pitch deck to white theme; update iOS pods
Co-Authored-By: Claude Opus 5.5 <noreply@anthropic.com>
</commit_message>
<xml_diff>
--- a/pitch_materials/Protiti_Pitch_Deck.pptx
+++ b/pitch_materials/Protiti_Pitch_Deck.pptx
@@ -3110,7 +3110,7 @@
             <a:avLst/>
           </a:prstGeom>
           <a:solidFill>
-            <a:srgbClr val="280C2A"/>
+            <a:srgbClr val="F7F2F8"/>
           </a:solidFill>
           <a:ln>
             <a:noFill/>
@@ -3206,7 +3206,7 @@
             <a:pPr>
               <a:defRPr sz="1100" b="1">
                 <a:solidFill>
-                  <a:srgbClr val="FFC107"/>
+                  <a:srgbClr val="92400E"/>
                 </a:solidFill>
                 <a:latin typeface="Arial"/>
               </a:defRPr>
@@ -3219,7 +3219,7 @@
             <a:pPr>
               <a:defRPr sz="4000" b="1">
                 <a:solidFill>
-                  <a:srgbClr val="FFFFFF"/>
+                  <a:srgbClr val="18181B"/>
                 </a:solidFill>
                 <a:latin typeface="Arial"/>
               </a:defRPr>
@@ -3232,7 +3232,7 @@
             <a:pPr>
               <a:defRPr sz="1600">
                 <a:solidFill>
-                  <a:srgbClr val="008080"/>
+                  <a:srgbClr val="00695C"/>
                 </a:solidFill>
                 <a:latin typeface="Arial"/>
               </a:defRPr>
@@ -3250,7 +3250,7 @@
             <a:pPr>
               <a:defRPr sz="1300">
                 <a:solidFill>
-                  <a:srgbClr val="F0F0F5"/>
+                  <a:srgbClr val="3F3F46"/>
                 </a:solidFill>
                 <a:latin typeface="Arial"/>
               </a:defRPr>
@@ -3264,7 +3264,7 @@
             <a:pPr>
               <a:defRPr sz="1100">
                 <a:solidFill>
-                  <a:srgbClr val="A0A0AA"/>
+                  <a:srgbClr val="6B7280"/>
                 </a:solidFill>
                 <a:latin typeface="Arial"/>
               </a:defRPr>
@@ -3294,13 +3294,14 @@
             <a:avLst/>
           </a:prstGeom>
           <a:solidFill>
-            <a:srgbClr val="1C1C1E"/>
+            <a:srgbClr val="FFFFFF"/>
           </a:solidFill>
           <a:ln w="19050">
             <a:solidFill>
               <a:srgbClr val="4A154B"/>
             </a:solidFill>
           </a:ln>
+          <a:effectLst/>
         </p:spPr>
         <p:style>
           <a:lnRef idx="1">
@@ -3349,7 +3350,7 @@
             <a:pPr>
               <a:defRPr sz="1400" b="1">
                 <a:solidFill>
-                  <a:srgbClr val="FFC107"/>
+                  <a:srgbClr val="92400E"/>
                 </a:solidFill>
                 <a:latin typeface="Arial"/>
               </a:defRPr>
@@ -3385,7 +3386,7 @@
             <a:pPr>
               <a:defRPr sz="1000" b="1">
                 <a:solidFill>
-                  <a:srgbClr val="FFFFFF"/>
+                  <a:srgbClr val="18181B"/>
                 </a:solidFill>
               </a:defRPr>
             </a:pPr>
@@ -3397,7 +3398,7 @@
             <a:pPr>
               <a:defRPr sz="1100" b="1">
                 <a:solidFill>
-                  <a:srgbClr val="FFC107"/>
+                  <a:srgbClr val="92400E"/>
                 </a:solidFill>
               </a:defRPr>
             </a:pPr>
@@ -3409,7 +3410,7 @@
             <a:pPr>
               <a:defRPr sz="900">
                 <a:solidFill>
-                  <a:srgbClr val="F0F0F5"/>
+                  <a:srgbClr val="3F3F46"/>
                 </a:solidFill>
               </a:defRPr>
             </a:pPr>
@@ -3421,7 +3422,7 @@
             <a:pPr>
               <a:defRPr sz="1100" b="1">
                 <a:solidFill>
-                  <a:srgbClr val="008080"/>
+                  <a:srgbClr val="00695C"/>
                 </a:solidFill>
               </a:defRPr>
             </a:pPr>
@@ -3433,7 +3434,7 @@
             <a:pPr>
               <a:defRPr sz="900">
                 <a:solidFill>
-                  <a:srgbClr val="F0F0F5"/>
+                  <a:srgbClr val="3F3F46"/>
                 </a:solidFill>
               </a:defRPr>
             </a:pPr>
@@ -3445,7 +3446,7 @@
             <a:pPr>
               <a:defRPr sz="1100" b="1">
                 <a:solidFill>
-                  <a:srgbClr val="FFFFFF"/>
+                  <a:srgbClr val="18181B"/>
                 </a:solidFill>
               </a:defRPr>
             </a:pPr>
@@ -3457,7 +3458,7 @@
             <a:pPr>
               <a:defRPr sz="900">
                 <a:solidFill>
-                  <a:srgbClr val="F0F0F5"/>
+                  <a:srgbClr val="3F3F46"/>
                 </a:solidFill>
               </a:defRPr>
             </a:pPr>
@@ -3469,7 +3470,7 @@
             <a:pPr>
               <a:defRPr sz="1100" b="1">
                 <a:solidFill>
-                  <a:srgbClr val="A0A0AA"/>
+                  <a:srgbClr val="6B7280"/>
                 </a:solidFill>
               </a:defRPr>
             </a:pPr>
@@ -3481,7 +3482,7 @@
             <a:pPr>
               <a:defRPr sz="900">
                 <a:solidFill>
-                  <a:srgbClr val="F0F0F5"/>
+                  <a:srgbClr val="3F3F46"/>
                 </a:solidFill>
               </a:defRPr>
             </a:pPr>
@@ -3493,7 +3494,7 @@
             <a:pPr>
               <a:defRPr sz="1100" b="1">
                 <a:solidFill>
-                  <a:srgbClr val="A0A0AA"/>
+                  <a:srgbClr val="6B7280"/>
                 </a:solidFill>
               </a:defRPr>
             </a:pPr>
@@ -3505,7 +3506,7 @@
             <a:pPr>
               <a:defRPr sz="900">
                 <a:solidFill>
-                  <a:srgbClr val="F0F0F5"/>
+                  <a:srgbClr val="3F3F46"/>
                 </a:solidFill>
               </a:defRPr>
             </a:pPr>
@@ -3518,7 +3519,7 @@
             <a:pPr>
               <a:defRPr sz="950" b="1">
                 <a:solidFill>
-                  <a:srgbClr val="D32F2F"/>
+                  <a:srgbClr val="C62828"/>
                 </a:solidFill>
               </a:defRPr>
             </a:pPr>
@@ -3565,7 +3566,7 @@
             <a:avLst/>
           </a:prstGeom>
           <a:solidFill>
-            <a:srgbClr val="121212"/>
+            <a:srgbClr val="FFFFFF"/>
           </a:solidFill>
           <a:ln>
             <a:noFill/>
@@ -3633,7 +3634,7 @@
             <a:pPr algn="ctr">
               <a:defRPr sz="1000" b="1">
                 <a:solidFill>
-                  <a:srgbClr val="FFC107"/>
+                  <a:srgbClr val="92400E"/>
                 </a:solidFill>
                 <a:latin typeface="Arial"/>
               </a:defRPr>
@@ -3646,7 +3647,7 @@
             <a:pPr>
               <a:defRPr sz="2400" b="1">
                 <a:solidFill>
-                  <a:srgbClr val="FFFFFF"/>
+                  <a:srgbClr val="18181B"/>
                 </a:solidFill>
                 <a:latin typeface="Arial"/>
               </a:defRPr>
@@ -3659,7 +3660,7 @@
             <a:pPr>
               <a:defRPr sz="1200">
                 <a:solidFill>
-                  <a:srgbClr val="008080"/>
+                  <a:srgbClr val="00695C"/>
                 </a:solidFill>
                 <a:latin typeface="Arial"/>
               </a:defRPr>
@@ -3685,13 +3686,14 @@
             <a:avLst/>
           </a:prstGeom>
           <a:solidFill>
-            <a:srgbClr val="1C1C1E"/>
+            <a:srgbClr val="FFFFFF"/>
           </a:solidFill>
           <a:ln w="19050">
             <a:solidFill>
-              <a:srgbClr val="D32F2F"/>
+              <a:srgbClr val="C62828"/>
             </a:solidFill>
           </a:ln>
+          <a:effectLst/>
         </p:spPr>
         <p:style>
           <a:lnRef idx="1">
@@ -3740,7 +3742,7 @@
             <a:pPr>
               <a:defRPr sz="1400" b="1">
                 <a:solidFill>
-                  <a:srgbClr val="FFC107"/>
+                  <a:srgbClr val="92400E"/>
                 </a:solidFill>
                 <a:latin typeface="Arial"/>
               </a:defRPr>
@@ -3776,7 +3778,7 @@
             <a:pPr>
               <a:defRPr sz="1100">
                 <a:solidFill>
-                  <a:srgbClr val="F0F0F5"/>
+                  <a:srgbClr val="3F3F46"/>
                 </a:solidFill>
               </a:defRPr>
             </a:pPr>
@@ -3789,7 +3791,7 @@
             <a:pPr>
               <a:defRPr sz="1000" b="1">
                 <a:solidFill>
-                  <a:srgbClr val="FFC107"/>
+                  <a:srgbClr val="92400E"/>
                 </a:solidFill>
               </a:defRPr>
             </a:pPr>
@@ -3814,13 +3816,14 @@
             <a:avLst/>
           </a:prstGeom>
           <a:solidFill>
-            <a:srgbClr val="1C1C1E"/>
+            <a:srgbClr val="FFFFFF"/>
           </a:solidFill>
           <a:ln w="19050">
             <a:solidFill>
               <a:srgbClr val="FFC107"/>
             </a:solidFill>
           </a:ln>
+          <a:effectLst/>
         </p:spPr>
         <p:style>
           <a:lnRef idx="1">
@@ -3869,7 +3872,7 @@
             <a:pPr>
               <a:defRPr sz="1400" b="1">
                 <a:solidFill>
-                  <a:srgbClr val="FFC107"/>
+                  <a:srgbClr val="92400E"/>
                 </a:solidFill>
                 <a:latin typeface="Arial"/>
               </a:defRPr>
@@ -3905,7 +3908,7 @@
             <a:pPr>
               <a:defRPr sz="1100">
                 <a:solidFill>
-                  <a:srgbClr val="F0F0F5"/>
+                  <a:srgbClr val="3F3F46"/>
                 </a:solidFill>
               </a:defRPr>
             </a:pPr>
@@ -3918,7 +3921,7 @@
             <a:pPr>
               <a:defRPr sz="1000" b="1">
                 <a:solidFill>
-                  <a:srgbClr val="008080"/>
+                  <a:srgbClr val="00695C"/>
                 </a:solidFill>
               </a:defRPr>
             </a:pPr>
@@ -3943,13 +3946,14 @@
             <a:avLst/>
           </a:prstGeom>
           <a:solidFill>
-            <a:srgbClr val="1C1C1E"/>
+            <a:srgbClr val="FFFFFF"/>
           </a:solidFill>
           <a:ln w="19050">
             <a:solidFill>
-              <a:srgbClr val="008080"/>
+              <a:srgbClr val="00695C"/>
             </a:solidFill>
           </a:ln>
+          <a:effectLst/>
         </p:spPr>
         <p:style>
           <a:lnRef idx="1">
@@ -3998,7 +4002,7 @@
             <a:pPr>
               <a:defRPr sz="1400" b="1">
                 <a:solidFill>
-                  <a:srgbClr val="FFC107"/>
+                  <a:srgbClr val="92400E"/>
                 </a:solidFill>
                 <a:latin typeface="Arial"/>
               </a:defRPr>
@@ -4034,7 +4038,7 @@
             <a:pPr>
               <a:defRPr sz="1100">
                 <a:solidFill>
-                  <a:srgbClr val="F0F0F5"/>
+                  <a:srgbClr val="3F3F46"/>
                 </a:solidFill>
               </a:defRPr>
             </a:pPr>
@@ -4047,7 +4051,7 @@
             <a:pPr>
               <a:defRPr sz="1000" b="1">
                 <a:solidFill>
-                  <a:srgbClr val="FFC107"/>
+                  <a:srgbClr val="92400E"/>
                 </a:solidFill>
               </a:defRPr>
             </a:pPr>
@@ -4072,13 +4076,14 @@
             <a:avLst/>
           </a:prstGeom>
           <a:solidFill>
-            <a:srgbClr val="1C1C1E"/>
+            <a:srgbClr val="FFFFFF"/>
           </a:solidFill>
           <a:ln w="19050">
             <a:solidFill>
               <a:srgbClr val="4A154B"/>
             </a:solidFill>
           </a:ln>
+          <a:effectLst/>
         </p:spPr>
         <p:style>
           <a:lnRef idx="1">
@@ -4127,7 +4132,7 @@
             <a:pPr>
               <a:defRPr sz="1400" b="1">
                 <a:solidFill>
-                  <a:srgbClr val="FFC107"/>
+                  <a:srgbClr val="92400E"/>
                 </a:solidFill>
                 <a:latin typeface="Arial"/>
               </a:defRPr>
@@ -4163,7 +4168,7 @@
             <a:pPr>
               <a:defRPr sz="1100">
                 <a:solidFill>
-                  <a:srgbClr val="F0F0F5"/>
+                  <a:srgbClr val="3F3F46"/>
                 </a:solidFill>
               </a:defRPr>
             </a:pPr>
@@ -4176,7 +4181,7 @@
             <a:pPr>
               <a:defRPr sz="1000" b="1">
                 <a:solidFill>
-                  <a:srgbClr val="FFC107"/>
+                  <a:srgbClr val="92400E"/>
                 </a:solidFill>
               </a:defRPr>
             </a:pPr>
@@ -4219,7 +4224,7 @@
             <a:avLst/>
           </a:prstGeom>
           <a:solidFill>
-            <a:srgbClr val="121212"/>
+            <a:srgbClr val="FFFFFF"/>
           </a:solidFill>
           <a:ln>
             <a:noFill/>
@@ -4287,7 +4292,7 @@
             <a:pPr algn="ctr">
               <a:defRPr sz="1000" b="1">
                 <a:solidFill>
-                  <a:srgbClr val="FFC107"/>
+                  <a:srgbClr val="92400E"/>
                 </a:solidFill>
                 <a:latin typeface="Arial"/>
               </a:defRPr>
@@ -4300,7 +4305,7 @@
             <a:pPr>
               <a:defRPr sz="2400" b="1">
                 <a:solidFill>
-                  <a:srgbClr val="FFFFFF"/>
+                  <a:srgbClr val="18181B"/>
                 </a:solidFill>
                 <a:latin typeface="Arial"/>
               </a:defRPr>
@@ -4313,7 +4318,7 @@
             <a:pPr>
               <a:defRPr sz="1200">
                 <a:solidFill>
-                  <a:srgbClr val="008080"/>
+                  <a:srgbClr val="00695C"/>
                 </a:solidFill>
                 <a:latin typeface="Arial"/>
               </a:defRPr>
@@ -4339,13 +4344,14 @@
             <a:avLst/>
           </a:prstGeom>
           <a:solidFill>
-            <a:srgbClr val="1C1C1E"/>
+            <a:srgbClr val="FFFFFF"/>
           </a:solidFill>
           <a:ln w="19050">
             <a:solidFill>
-              <a:srgbClr val="008080"/>
+              <a:srgbClr val="00695C"/>
             </a:solidFill>
           </a:ln>
+          <a:effectLst/>
         </p:spPr>
         <p:style>
           <a:lnRef idx="1">
@@ -4394,7 +4400,7 @@
             <a:pPr>
               <a:defRPr sz="1400" b="1">
                 <a:solidFill>
-                  <a:srgbClr val="FFC107"/>
+                  <a:srgbClr val="92400E"/>
                 </a:solidFill>
                 <a:latin typeface="Arial"/>
               </a:defRPr>
@@ -4430,7 +4436,7 @@
             <a:pPr>
               <a:defRPr sz="1100">
                 <a:solidFill>
-                  <a:srgbClr val="F0F0F5"/>
+                  <a:srgbClr val="3F3F46"/>
                 </a:solidFill>
               </a:defRPr>
             </a:pPr>
@@ -4463,13 +4469,14 @@
             <a:avLst/>
           </a:prstGeom>
           <a:solidFill>
-            <a:srgbClr val="1C1C1E"/>
+            <a:srgbClr val="FFFFFF"/>
           </a:solidFill>
           <a:ln w="19050">
             <a:solidFill>
               <a:srgbClr val="FFC107"/>
             </a:solidFill>
           </a:ln>
+          <a:effectLst/>
         </p:spPr>
         <p:style>
           <a:lnRef idx="1">
@@ -4518,7 +4525,7 @@
             <a:pPr>
               <a:defRPr sz="1400" b="1">
                 <a:solidFill>
-                  <a:srgbClr val="FFC107"/>
+                  <a:srgbClr val="92400E"/>
                 </a:solidFill>
                 <a:latin typeface="Arial"/>
               </a:defRPr>
@@ -4554,7 +4561,7 @@
             <a:pPr>
               <a:defRPr sz="1100">
                 <a:solidFill>
-                  <a:srgbClr val="F0F0F5"/>
+                  <a:srgbClr val="3F3F46"/>
                 </a:solidFill>
               </a:defRPr>
             </a:pPr>
@@ -4587,13 +4594,14 @@
             <a:avLst/>
           </a:prstGeom>
           <a:solidFill>
-            <a:srgbClr val="1C1C1E"/>
+            <a:srgbClr val="FFFFFF"/>
           </a:solidFill>
           <a:ln w="19050">
             <a:solidFill>
-              <a:srgbClr val="D32F2F"/>
+              <a:srgbClr val="C62828"/>
             </a:solidFill>
           </a:ln>
+          <a:effectLst/>
         </p:spPr>
         <p:style>
           <a:lnRef idx="1">
@@ -4642,7 +4650,7 @@
             <a:pPr>
               <a:defRPr sz="1400" b="1">
                 <a:solidFill>
-                  <a:srgbClr val="FFC107"/>
+                  <a:srgbClr val="92400E"/>
                 </a:solidFill>
                 <a:latin typeface="Arial"/>
               </a:defRPr>
@@ -4678,7 +4686,7 @@
             <a:pPr>
               <a:defRPr sz="1100">
                 <a:solidFill>
-                  <a:srgbClr val="F0F0F5"/>
+                  <a:srgbClr val="3F3F46"/>
                 </a:solidFill>
               </a:defRPr>
             </a:pPr>
@@ -4711,13 +4719,14 @@
             <a:avLst/>
           </a:prstGeom>
           <a:solidFill>
-            <a:srgbClr val="1C1C1E"/>
+            <a:srgbClr val="FFFFFF"/>
           </a:solidFill>
           <a:ln w="19050">
             <a:solidFill>
               <a:srgbClr val="4A154B"/>
             </a:solidFill>
           </a:ln>
+          <a:effectLst/>
         </p:spPr>
         <p:style>
           <a:lnRef idx="1">
@@ -4766,7 +4775,7 @@
             <a:pPr>
               <a:defRPr sz="1400" b="1">
                 <a:solidFill>
-                  <a:srgbClr val="FFC107"/>
+                  <a:srgbClr val="92400E"/>
                 </a:solidFill>
                 <a:latin typeface="Arial"/>
               </a:defRPr>
@@ -4802,7 +4811,7 @@
             <a:pPr>
               <a:defRPr sz="1100">
                 <a:solidFill>
-                  <a:srgbClr val="F0F0F5"/>
+                  <a:srgbClr val="3F3F46"/>
                 </a:solidFill>
               </a:defRPr>
             </a:pPr>
@@ -4853,7 +4862,7 @@
             <a:avLst/>
           </a:prstGeom>
           <a:solidFill>
-            <a:srgbClr val="121212"/>
+            <a:srgbClr val="FFFFFF"/>
           </a:solidFill>
           <a:ln>
             <a:noFill/>
@@ -4921,7 +4930,7 @@
             <a:pPr algn="ctr">
               <a:defRPr sz="1000" b="1">
                 <a:solidFill>
-                  <a:srgbClr val="FFC107"/>
+                  <a:srgbClr val="92400E"/>
                 </a:solidFill>
                 <a:latin typeface="Arial"/>
               </a:defRPr>
@@ -4934,7 +4943,7 @@
             <a:pPr>
               <a:defRPr sz="2400" b="1">
                 <a:solidFill>
-                  <a:srgbClr val="FFFFFF"/>
+                  <a:srgbClr val="18181B"/>
                 </a:solidFill>
                 <a:latin typeface="Arial"/>
               </a:defRPr>
@@ -4947,7 +4956,7 @@
             <a:pPr>
               <a:defRPr sz="1200">
                 <a:solidFill>
-                  <a:srgbClr val="008080"/>
+                  <a:srgbClr val="00695C"/>
                 </a:solidFill>
                 <a:latin typeface="Arial"/>
               </a:defRPr>
@@ -4973,13 +4982,14 @@
             <a:avLst/>
           </a:prstGeom>
           <a:solidFill>
-            <a:srgbClr val="1C1C1E"/>
+            <a:srgbClr val="FFFFFF"/>
           </a:solidFill>
           <a:ln w="19050">
             <a:solidFill>
-              <a:srgbClr val="008080"/>
+              <a:srgbClr val="00695C"/>
             </a:solidFill>
           </a:ln>
+          <a:effectLst/>
         </p:spPr>
         <p:style>
           <a:lnRef idx="1">
@@ -5028,7 +5038,7 @@
             <a:pPr>
               <a:defRPr sz="1400" b="1">
                 <a:solidFill>
-                  <a:srgbClr val="FFC107"/>
+                  <a:srgbClr val="92400E"/>
                 </a:solidFill>
                 <a:latin typeface="Arial"/>
               </a:defRPr>
@@ -5064,7 +5074,7 @@
             <a:pPr>
               <a:defRPr sz="1100">
                 <a:solidFill>
-                  <a:srgbClr val="F0F0F5"/>
+                  <a:srgbClr val="3F3F46"/>
                 </a:solidFill>
               </a:defRPr>
             </a:pPr>
@@ -5089,13 +5099,14 @@
             <a:avLst/>
           </a:prstGeom>
           <a:solidFill>
-            <a:srgbClr val="1C1C1E"/>
+            <a:srgbClr val="FFFFFF"/>
           </a:solidFill>
           <a:ln w="19050">
             <a:solidFill>
               <a:srgbClr val="FFC107"/>
             </a:solidFill>
           </a:ln>
+          <a:effectLst/>
         </p:spPr>
         <p:style>
           <a:lnRef idx="1">
@@ -5144,7 +5155,7 @@
             <a:pPr>
               <a:defRPr sz="1400" b="1">
                 <a:solidFill>
-                  <a:srgbClr val="FFC107"/>
+                  <a:srgbClr val="92400E"/>
                 </a:solidFill>
                 <a:latin typeface="Arial"/>
               </a:defRPr>
@@ -5180,7 +5191,7 @@
             <a:pPr>
               <a:defRPr sz="1100">
                 <a:solidFill>
-                  <a:srgbClr val="F0F0F5"/>
+                  <a:srgbClr val="3F3F46"/>
                 </a:solidFill>
               </a:defRPr>
             </a:pPr>
@@ -5205,13 +5216,14 @@
             <a:avLst/>
           </a:prstGeom>
           <a:solidFill>
-            <a:srgbClr val="1C1C1E"/>
+            <a:srgbClr val="FFFFFF"/>
           </a:solidFill>
           <a:ln w="19050">
             <a:solidFill>
               <a:srgbClr val="4A154B"/>
             </a:solidFill>
           </a:ln>
+          <a:effectLst/>
         </p:spPr>
         <p:style>
           <a:lnRef idx="1">
@@ -5260,7 +5272,7 @@
             <a:pPr>
               <a:defRPr sz="1400" b="1">
                 <a:solidFill>
-                  <a:srgbClr val="FFC107"/>
+                  <a:srgbClr val="92400E"/>
                 </a:solidFill>
                 <a:latin typeface="Arial"/>
               </a:defRPr>
@@ -5296,7 +5308,7 @@
             <a:pPr>
               <a:defRPr sz="1100">
                 <a:solidFill>
-                  <a:srgbClr val="F0F0F5"/>
+                  <a:srgbClr val="3F3F46"/>
                 </a:solidFill>
               </a:defRPr>
             </a:pPr>
@@ -5321,13 +5333,14 @@
             <a:avLst/>
           </a:prstGeom>
           <a:solidFill>
-            <a:srgbClr val="1C1C1E"/>
+            <a:srgbClr val="FFFFFF"/>
           </a:solidFill>
           <a:ln w="19050">
             <a:solidFill>
-              <a:srgbClr val="008080"/>
+              <a:srgbClr val="00695C"/>
             </a:solidFill>
           </a:ln>
+          <a:effectLst/>
         </p:spPr>
         <p:style>
           <a:lnRef idx="1">
@@ -5376,7 +5389,7 @@
             <a:pPr>
               <a:defRPr sz="1400" b="1">
                 <a:solidFill>
-                  <a:srgbClr val="FFC107"/>
+                  <a:srgbClr val="92400E"/>
                 </a:solidFill>
                 <a:latin typeface="Arial"/>
               </a:defRPr>
@@ -5412,7 +5425,7 @@
             <a:pPr>
               <a:defRPr sz="1100">
                 <a:solidFill>
-                  <a:srgbClr val="F0F0F5"/>
+                  <a:srgbClr val="3F3F46"/>
                 </a:solidFill>
               </a:defRPr>
             </a:pPr>
@@ -5437,13 +5450,14 @@
             <a:avLst/>
           </a:prstGeom>
           <a:solidFill>
-            <a:srgbClr val="1C1C1E"/>
+            <a:srgbClr val="FFFFFF"/>
           </a:solidFill>
           <a:ln w="19050">
             <a:solidFill>
-              <a:srgbClr val="D32F2F"/>
+              <a:srgbClr val="C62828"/>
             </a:solidFill>
           </a:ln>
+          <a:effectLst/>
         </p:spPr>
         <p:style>
           <a:lnRef idx="1">
@@ -5492,7 +5506,7 @@
             <a:pPr>
               <a:defRPr sz="1400" b="1">
                 <a:solidFill>
-                  <a:srgbClr val="FFC107"/>
+                  <a:srgbClr val="92400E"/>
                 </a:solidFill>
                 <a:latin typeface="Arial"/>
               </a:defRPr>
@@ -5528,7 +5542,7 @@
             <a:pPr>
               <a:defRPr sz="1100">
                 <a:solidFill>
-                  <a:srgbClr val="F0F0F5"/>
+                  <a:srgbClr val="3F3F46"/>
                 </a:solidFill>
               </a:defRPr>
             </a:pPr>
@@ -5553,13 +5567,14 @@
             <a:avLst/>
           </a:prstGeom>
           <a:solidFill>
-            <a:srgbClr val="1C1C1E"/>
+            <a:srgbClr val="FFFFFF"/>
           </a:solidFill>
           <a:ln w="19050">
             <a:solidFill>
               <a:srgbClr val="FFC107"/>
             </a:solidFill>
           </a:ln>
+          <a:effectLst/>
         </p:spPr>
         <p:style>
           <a:lnRef idx="1">
@@ -5608,7 +5623,7 @@
             <a:pPr>
               <a:defRPr sz="1400" b="1">
                 <a:solidFill>
-                  <a:srgbClr val="FFC107"/>
+                  <a:srgbClr val="92400E"/>
                 </a:solidFill>
                 <a:latin typeface="Arial"/>
               </a:defRPr>
@@ -5644,7 +5659,7 @@
             <a:pPr>
               <a:defRPr sz="1050" b="1">
                 <a:solidFill>
-                  <a:srgbClr val="FFFFFF"/>
+                  <a:srgbClr val="18181B"/>
                 </a:solidFill>
               </a:defRPr>
             </a:pPr>
@@ -5691,7 +5706,7 @@
             <a:avLst/>
           </a:prstGeom>
           <a:solidFill>
-            <a:srgbClr val="121212"/>
+            <a:srgbClr val="FFFFFF"/>
           </a:solidFill>
           <a:ln>
             <a:noFill/>
@@ -5759,7 +5774,7 @@
             <a:pPr algn="ctr">
               <a:defRPr sz="1000" b="1">
                 <a:solidFill>
-                  <a:srgbClr val="FFC107"/>
+                  <a:srgbClr val="92400E"/>
                 </a:solidFill>
                 <a:latin typeface="Arial"/>
               </a:defRPr>
@@ -5772,7 +5787,7 @@
             <a:pPr>
               <a:defRPr sz="2400" b="1">
                 <a:solidFill>
-                  <a:srgbClr val="FFFFFF"/>
+                  <a:srgbClr val="18181B"/>
                 </a:solidFill>
                 <a:latin typeface="Arial"/>
               </a:defRPr>
@@ -5785,7 +5800,7 @@
             <a:pPr>
               <a:defRPr sz="1200">
                 <a:solidFill>
-                  <a:srgbClr val="008080"/>
+                  <a:srgbClr val="00695C"/>
                 </a:solidFill>
                 <a:latin typeface="Arial"/>
               </a:defRPr>
@@ -5811,13 +5826,14 @@
             <a:avLst/>
           </a:prstGeom>
           <a:solidFill>
-            <a:srgbClr val="1C1C1E"/>
+            <a:srgbClr val="FFFFFF"/>
           </a:solidFill>
           <a:ln w="19050">
             <a:solidFill>
-              <a:srgbClr val="008080"/>
+              <a:srgbClr val="00695C"/>
             </a:solidFill>
           </a:ln>
+          <a:effectLst/>
         </p:spPr>
         <p:style>
           <a:lnRef idx="1">
@@ -5866,7 +5882,7 @@
             <a:pPr>
               <a:defRPr sz="1400" b="1">
                 <a:solidFill>
-                  <a:srgbClr val="FFC107"/>
+                  <a:srgbClr val="92400E"/>
                 </a:solidFill>
                 <a:latin typeface="Arial"/>
               </a:defRPr>
@@ -5902,7 +5918,7 @@
             <a:pPr>
               <a:defRPr sz="1100">
                 <a:solidFill>
-                  <a:srgbClr val="F0F0F5"/>
+                  <a:srgbClr val="3F3F46"/>
                 </a:solidFill>
               </a:defRPr>
             </a:pPr>
@@ -5927,13 +5943,14 @@
             <a:avLst/>
           </a:prstGeom>
           <a:solidFill>
-            <a:srgbClr val="1C1C1E"/>
+            <a:srgbClr val="FFFFFF"/>
           </a:solidFill>
           <a:ln w="19050">
             <a:solidFill>
               <a:srgbClr val="4A154B"/>
             </a:solidFill>
           </a:ln>
+          <a:effectLst/>
         </p:spPr>
         <p:style>
           <a:lnRef idx="1">
@@ -5982,7 +5999,7 @@
             <a:pPr>
               <a:defRPr sz="1400" b="1">
                 <a:solidFill>
-                  <a:srgbClr val="FFC107"/>
+                  <a:srgbClr val="92400E"/>
                 </a:solidFill>
                 <a:latin typeface="Arial"/>
               </a:defRPr>
@@ -6018,7 +6035,7 @@
             <a:pPr>
               <a:defRPr sz="1100">
                 <a:solidFill>
-                  <a:srgbClr val="F0F0F5"/>
+                  <a:srgbClr val="3F3F46"/>
                 </a:solidFill>
               </a:defRPr>
             </a:pPr>
@@ -6043,13 +6060,14 @@
             <a:avLst/>
           </a:prstGeom>
           <a:solidFill>
-            <a:srgbClr val="1C1C1E"/>
+            <a:srgbClr val="FFFFFF"/>
           </a:solidFill>
           <a:ln w="19050">
             <a:solidFill>
-              <a:srgbClr val="D32F2F"/>
+              <a:srgbClr val="C62828"/>
             </a:solidFill>
           </a:ln>
+          <a:effectLst/>
         </p:spPr>
         <p:style>
           <a:lnRef idx="1">
@@ -6098,7 +6116,7 @@
             <a:pPr>
               <a:defRPr sz="1400" b="1">
                 <a:solidFill>
-                  <a:srgbClr val="FFC107"/>
+                  <a:srgbClr val="92400E"/>
                 </a:solidFill>
                 <a:latin typeface="Arial"/>
               </a:defRPr>
@@ -6134,7 +6152,7 @@
             <a:pPr>
               <a:defRPr sz="1100">
                 <a:solidFill>
-                  <a:srgbClr val="F0F0F5"/>
+                  <a:srgbClr val="3F3F46"/>
                 </a:solidFill>
               </a:defRPr>
             </a:pPr>
@@ -6159,13 +6177,14 @@
             <a:avLst/>
           </a:prstGeom>
           <a:solidFill>
-            <a:srgbClr val="1C1C1E"/>
+            <a:srgbClr val="FFFFFF"/>
           </a:solidFill>
           <a:ln w="19050">
             <a:solidFill>
               <a:srgbClr val="FFC107"/>
             </a:solidFill>
           </a:ln>
+          <a:effectLst/>
         </p:spPr>
         <p:style>
           <a:lnRef idx="1">
@@ -6214,7 +6233,7 @@
             <a:pPr>
               <a:defRPr sz="1400" b="1">
                 <a:solidFill>
-                  <a:srgbClr val="FFC107"/>
+                  <a:srgbClr val="92400E"/>
                 </a:solidFill>
                 <a:latin typeface="Arial"/>
               </a:defRPr>
@@ -6250,7 +6269,7 @@
             <a:pPr>
               <a:defRPr sz="1100">
                 <a:solidFill>
-                  <a:srgbClr val="F0F0F5"/>
+                  <a:srgbClr val="3F3F46"/>
                 </a:solidFill>
               </a:defRPr>
             </a:pPr>
@@ -6293,7 +6312,7 @@
             <a:avLst/>
           </a:prstGeom>
           <a:solidFill>
-            <a:srgbClr val="121212"/>
+            <a:srgbClr val="FFFFFF"/>
           </a:solidFill>
           <a:ln>
             <a:noFill/>
@@ -6361,7 +6380,7 @@
             <a:pPr algn="ctr">
               <a:defRPr sz="1000" b="1">
                 <a:solidFill>
-                  <a:srgbClr val="FFC107"/>
+                  <a:srgbClr val="92400E"/>
                 </a:solidFill>
                 <a:latin typeface="Arial"/>
               </a:defRPr>
@@ -6374,7 +6393,7 @@
             <a:pPr>
               <a:defRPr sz="2400" b="1">
                 <a:solidFill>
-                  <a:srgbClr val="FFFFFF"/>
+                  <a:srgbClr val="18181B"/>
                 </a:solidFill>
                 <a:latin typeface="Arial"/>
               </a:defRPr>
@@ -6387,7 +6406,7 @@
             <a:pPr>
               <a:defRPr sz="1200">
                 <a:solidFill>
-                  <a:srgbClr val="008080"/>
+                  <a:srgbClr val="00695C"/>
                 </a:solidFill>
                 <a:latin typeface="Arial"/>
               </a:defRPr>
@@ -6413,13 +6432,14 @@
             <a:avLst/>
           </a:prstGeom>
           <a:solidFill>
-            <a:srgbClr val="1C1C1E"/>
+            <a:srgbClr val="FFFFFF"/>
           </a:solidFill>
           <a:ln w="19050">
             <a:solidFill>
-              <a:srgbClr val="008080"/>
+              <a:srgbClr val="00695C"/>
             </a:solidFill>
           </a:ln>
+          <a:effectLst/>
         </p:spPr>
         <p:style>
           <a:lnRef idx="1">
@@ -6468,7 +6488,7 @@
             <a:pPr>
               <a:defRPr sz="1400" b="1">
                 <a:solidFill>
-                  <a:srgbClr val="FFC107"/>
+                  <a:srgbClr val="92400E"/>
                 </a:solidFill>
                 <a:latin typeface="Arial"/>
               </a:defRPr>
@@ -6504,7 +6524,7 @@
             <a:pPr>
               <a:defRPr b="1" sz="1100">
                 <a:solidFill>
-                  <a:srgbClr val="FFC107"/>
+                  <a:srgbClr val="92400E"/>
                 </a:solidFill>
               </a:defRPr>
             </a:pPr>
@@ -6516,7 +6536,7 @@
             <a:pPr>
               <a:defRPr sz="1000">
                 <a:solidFill>
-                  <a:srgbClr val="F0F0F5"/>
+                  <a:srgbClr val="3F3F46"/>
                 </a:solidFill>
               </a:defRPr>
             </a:pPr>
@@ -6529,7 +6549,7 @@
             <a:pPr>
               <a:defRPr b="1" sz="1100">
                 <a:solidFill>
-                  <a:srgbClr val="FFC107"/>
+                  <a:srgbClr val="92400E"/>
                 </a:solidFill>
               </a:defRPr>
             </a:pPr>
@@ -6541,7 +6561,7 @@
             <a:pPr>
               <a:defRPr sz="1000">
                 <a:solidFill>
-                  <a:srgbClr val="F0F0F5"/>
+                  <a:srgbClr val="3F3F46"/>
                 </a:solidFill>
               </a:defRPr>
             </a:pPr>
@@ -6554,7 +6574,7 @@
             <a:pPr>
               <a:defRPr b="1" sz="1100">
                 <a:solidFill>
-                  <a:srgbClr val="FFC107"/>
+                  <a:srgbClr val="92400E"/>
                 </a:solidFill>
               </a:defRPr>
             </a:pPr>
@@ -6566,7 +6586,7 @@
             <a:pPr>
               <a:defRPr sz="1000">
                 <a:solidFill>
-                  <a:srgbClr val="F0F0F5"/>
+                  <a:srgbClr val="3F3F46"/>
                 </a:solidFill>
               </a:defRPr>
             </a:pPr>
@@ -6592,13 +6612,14 @@
             <a:avLst/>
           </a:prstGeom>
           <a:solidFill>
-            <a:srgbClr val="1C1C1E"/>
+            <a:srgbClr val="FFFFFF"/>
           </a:solidFill>
           <a:ln w="19050">
             <a:solidFill>
               <a:srgbClr val="FFC107"/>
             </a:solidFill>
           </a:ln>
+          <a:effectLst/>
         </p:spPr>
         <p:style>
           <a:lnRef idx="1">
@@ -6647,7 +6668,7 @@
             <a:pPr>
               <a:defRPr sz="1400" b="1">
                 <a:solidFill>
-                  <a:srgbClr val="FFC107"/>
+                  <a:srgbClr val="92400E"/>
                 </a:solidFill>
                 <a:latin typeface="Arial"/>
               </a:defRPr>
@@ -6683,7 +6704,7 @@
             <a:pPr>
               <a:defRPr b="1" sz="1100">
                 <a:solidFill>
-                  <a:srgbClr val="008080"/>
+                  <a:srgbClr val="00695C"/>
                 </a:solidFill>
               </a:defRPr>
             </a:pPr>
@@ -6695,7 +6716,7 @@
             <a:pPr>
               <a:defRPr sz="950">
                 <a:solidFill>
-                  <a:srgbClr val="F0F0F5"/>
+                  <a:srgbClr val="3F3F46"/>
                 </a:solidFill>
               </a:defRPr>
             </a:pPr>
@@ -6707,7 +6728,7 @@
             <a:pPr>
               <a:defRPr b="1" sz="1100">
                 <a:solidFill>
-                  <a:srgbClr val="008080"/>
+                  <a:srgbClr val="00695C"/>
                 </a:solidFill>
               </a:defRPr>
             </a:pPr>
@@ -6719,7 +6740,7 @@
             <a:pPr>
               <a:defRPr sz="950">
                 <a:solidFill>
-                  <a:srgbClr val="F0F0F5"/>
+                  <a:srgbClr val="3F3F46"/>
                 </a:solidFill>
               </a:defRPr>
             </a:pPr>
@@ -6731,7 +6752,7 @@
             <a:pPr>
               <a:defRPr b="1" sz="1100">
                 <a:solidFill>
-                  <a:srgbClr val="008080"/>
+                  <a:srgbClr val="00695C"/>
                 </a:solidFill>
               </a:defRPr>
             </a:pPr>
@@ -6743,7 +6764,7 @@
             <a:pPr>
               <a:defRPr sz="950">
                 <a:solidFill>
-                  <a:srgbClr val="F0F0F5"/>
+                  <a:srgbClr val="3F3F46"/>
                 </a:solidFill>
               </a:defRPr>
             </a:pPr>
@@ -6755,7 +6776,7 @@
             <a:pPr>
               <a:defRPr b="1" sz="1100">
                 <a:solidFill>
-                  <a:srgbClr val="008080"/>
+                  <a:srgbClr val="00695C"/>
                 </a:solidFill>
               </a:defRPr>
             </a:pPr>
@@ -6767,7 +6788,7 @@
             <a:pPr>
               <a:defRPr sz="950">
                 <a:solidFill>
-                  <a:srgbClr val="F0F0F5"/>
+                  <a:srgbClr val="3F3F46"/>
                 </a:solidFill>
               </a:defRPr>
             </a:pPr>
@@ -6779,7 +6800,7 @@
             <a:pPr>
               <a:defRPr b="1" sz="1100">
                 <a:solidFill>
-                  <a:srgbClr val="008080"/>
+                  <a:srgbClr val="00695C"/>
                 </a:solidFill>
               </a:defRPr>
             </a:pPr>
@@ -6791,7 +6812,7 @@
             <a:pPr>
               <a:defRPr sz="950">
                 <a:solidFill>
-                  <a:srgbClr val="F0F0F5"/>
+                  <a:srgbClr val="3F3F46"/>
                 </a:solidFill>
               </a:defRPr>
             </a:pPr>
@@ -6834,7 +6855,7 @@
             <a:avLst/>
           </a:prstGeom>
           <a:solidFill>
-            <a:srgbClr val="121212"/>
+            <a:srgbClr val="FFFFFF"/>
           </a:solidFill>
           <a:ln>
             <a:noFill/>
@@ -6902,7 +6923,7 @@
             <a:pPr algn="ctr">
               <a:defRPr sz="1000" b="1">
                 <a:solidFill>
-                  <a:srgbClr val="FFC107"/>
+                  <a:srgbClr val="92400E"/>
                 </a:solidFill>
                 <a:latin typeface="Arial"/>
               </a:defRPr>
@@ -6915,7 +6936,7 @@
             <a:pPr>
               <a:defRPr sz="2400" b="1">
                 <a:solidFill>
-                  <a:srgbClr val="FFFFFF"/>
+                  <a:srgbClr val="18181B"/>
                 </a:solidFill>
                 <a:latin typeface="Arial"/>
               </a:defRPr>
@@ -6928,7 +6949,7 @@
             <a:pPr>
               <a:defRPr sz="1200">
                 <a:solidFill>
-                  <a:srgbClr val="008080"/>
+                  <a:srgbClr val="00695C"/>
                 </a:solidFill>
                 <a:latin typeface="Arial"/>
               </a:defRPr>
@@ -6954,13 +6975,14 @@
             <a:avLst/>
           </a:prstGeom>
           <a:solidFill>
-            <a:srgbClr val="1C1C1E"/>
+            <a:srgbClr val="FFFFFF"/>
           </a:solidFill>
           <a:ln w="19050">
             <a:solidFill>
               <a:srgbClr val="4A154B"/>
             </a:solidFill>
           </a:ln>
+          <a:effectLst/>
         </p:spPr>
         <p:style>
           <a:lnRef idx="1">
@@ -7009,7 +7031,7 @@
             <a:pPr>
               <a:defRPr sz="1400" b="1">
                 <a:solidFill>
-                  <a:srgbClr val="FFC107"/>
+                  <a:srgbClr val="92400E"/>
                 </a:solidFill>
                 <a:latin typeface="Arial"/>
               </a:defRPr>
@@ -7045,7 +7067,7 @@
             <a:pPr>
               <a:defRPr b="1" sz="1100">
                 <a:solidFill>
-                  <a:srgbClr val="FFC107"/>
+                  <a:srgbClr val="92400E"/>
                 </a:solidFill>
               </a:defRPr>
             </a:pPr>
@@ -7057,7 +7079,7 @@
             <a:pPr>
               <a:defRPr sz="950">
                 <a:solidFill>
-                  <a:srgbClr val="F0F0F5"/>
+                  <a:srgbClr val="3F3F46"/>
                 </a:solidFill>
               </a:defRPr>
             </a:pPr>
@@ -7070,7 +7092,7 @@
             <a:pPr>
               <a:defRPr b="1" sz="1100">
                 <a:solidFill>
-                  <a:srgbClr val="FFC107"/>
+                  <a:srgbClr val="92400E"/>
                 </a:solidFill>
               </a:defRPr>
             </a:pPr>
@@ -7082,7 +7104,7 @@
             <a:pPr>
               <a:defRPr sz="950">
                 <a:solidFill>
-                  <a:srgbClr val="F0F0F5"/>
+                  <a:srgbClr val="3F3F46"/>
                 </a:solidFill>
               </a:defRPr>
             </a:pPr>
@@ -7095,7 +7117,7 @@
             <a:pPr>
               <a:defRPr b="1" sz="1100">
                 <a:solidFill>
-                  <a:srgbClr val="FFC107"/>
+                  <a:srgbClr val="92400E"/>
                 </a:solidFill>
               </a:defRPr>
             </a:pPr>
@@ -7107,7 +7129,7 @@
             <a:pPr>
               <a:defRPr sz="950">
                 <a:solidFill>
-                  <a:srgbClr val="F0F0F5"/>
+                  <a:srgbClr val="3F3F46"/>
                 </a:solidFill>
               </a:defRPr>
             </a:pPr>
@@ -7133,13 +7155,14 @@
             <a:avLst/>
           </a:prstGeom>
           <a:solidFill>
-            <a:srgbClr val="1C1C1E"/>
+            <a:srgbClr val="FFFFFF"/>
           </a:solidFill>
           <a:ln w="19050">
             <a:solidFill>
               <a:srgbClr val="FFC107"/>
             </a:solidFill>
           </a:ln>
+          <a:effectLst/>
         </p:spPr>
         <p:style>
           <a:lnRef idx="1">
@@ -7188,7 +7211,7 @@
             <a:pPr>
               <a:defRPr sz="1400" b="1">
                 <a:solidFill>
-                  <a:srgbClr val="FFC107"/>
+                  <a:srgbClr val="92400E"/>
                 </a:solidFill>
                 <a:latin typeface="Arial"/>
               </a:defRPr>
@@ -7224,7 +7247,7 @@
             <a:pPr>
               <a:defRPr b="1" sz="1050">
                 <a:solidFill>
-                  <a:srgbClr val="008080"/>
+                  <a:srgbClr val="00695C"/>
                 </a:solidFill>
               </a:defRPr>
             </a:pPr>
@@ -7236,7 +7259,7 @@
             <a:pPr>
               <a:defRPr sz="900">
                 <a:solidFill>
-                  <a:srgbClr val="F0F0F5"/>
+                  <a:srgbClr val="3F3F46"/>
                 </a:solidFill>
               </a:defRPr>
             </a:pPr>
@@ -7248,7 +7271,7 @@
             <a:pPr>
               <a:defRPr b="1" sz="1050">
                 <a:solidFill>
-                  <a:srgbClr val="008080"/>
+                  <a:srgbClr val="00695C"/>
                 </a:solidFill>
               </a:defRPr>
             </a:pPr>
@@ -7260,7 +7283,7 @@
             <a:pPr>
               <a:defRPr sz="900">
                 <a:solidFill>
-                  <a:srgbClr val="F0F0F5"/>
+                  <a:srgbClr val="3F3F46"/>
                 </a:solidFill>
               </a:defRPr>
             </a:pPr>
@@ -7272,7 +7295,7 @@
             <a:pPr>
               <a:defRPr b="1" sz="1050">
                 <a:solidFill>
-                  <a:srgbClr val="008080"/>
+                  <a:srgbClr val="00695C"/>
                 </a:solidFill>
               </a:defRPr>
             </a:pPr>
@@ -7284,7 +7307,7 @@
             <a:pPr>
               <a:defRPr sz="900">
                 <a:solidFill>
-                  <a:srgbClr val="F0F0F5"/>
+                  <a:srgbClr val="3F3F46"/>
                 </a:solidFill>
               </a:defRPr>
             </a:pPr>
@@ -7296,7 +7319,7 @@
             <a:pPr>
               <a:defRPr b="1" sz="1050">
                 <a:solidFill>
-                  <a:srgbClr val="008080"/>
+                  <a:srgbClr val="00695C"/>
                 </a:solidFill>
               </a:defRPr>
             </a:pPr>
@@ -7308,7 +7331,7 @@
             <a:pPr>
               <a:defRPr sz="900">
                 <a:solidFill>
-                  <a:srgbClr val="F0F0F5"/>
+                  <a:srgbClr val="3F3F46"/>
                 </a:solidFill>
               </a:defRPr>
             </a:pPr>
@@ -7320,7 +7343,7 @@
             <a:pPr>
               <a:defRPr b="1" sz="1050">
                 <a:solidFill>
-                  <a:srgbClr val="008080"/>
+                  <a:srgbClr val="00695C"/>
                 </a:solidFill>
               </a:defRPr>
             </a:pPr>
@@ -7332,7 +7355,7 @@
             <a:pPr>
               <a:defRPr sz="900">
                 <a:solidFill>
-                  <a:srgbClr val="F0F0F5"/>
+                  <a:srgbClr val="3F3F46"/>
                 </a:solidFill>
               </a:defRPr>
             </a:pPr>
@@ -7345,7 +7368,7 @@
             <a:pPr>
               <a:defRPr sz="850" b="1">
                 <a:solidFill>
-                  <a:srgbClr val="FFC107"/>
+                  <a:srgbClr val="92400E"/>
                 </a:solidFill>
               </a:defRPr>
             </a:pPr>
@@ -7388,7 +7411,7 @@
             <a:avLst/>
           </a:prstGeom>
           <a:solidFill>
-            <a:srgbClr val="280C2A"/>
+            <a:srgbClr val="F7F2F8"/>
           </a:solidFill>
           <a:ln>
             <a:noFill/>
@@ -7484,7 +7507,7 @@
             <a:pPr>
               <a:defRPr sz="1100" b="1">
                 <a:solidFill>
-                  <a:srgbClr val="FFC107"/>
+                  <a:srgbClr val="92400E"/>
                 </a:solidFill>
                 <a:latin typeface="Arial"/>
               </a:defRPr>
@@ -7497,7 +7520,7 @@
             <a:pPr>
               <a:defRPr sz="3200" b="1">
                 <a:solidFill>
-                  <a:srgbClr val="FFFFFF"/>
+                  <a:srgbClr val="18181B"/>
                 </a:solidFill>
                 <a:latin typeface="Arial"/>
               </a:defRPr>
@@ -7511,7 +7534,7 @@
             <a:pPr>
               <a:defRPr sz="1300" b="1">
                 <a:solidFill>
-                  <a:srgbClr val="008080"/>
+                  <a:srgbClr val="00695C"/>
                 </a:solidFill>
               </a:defRPr>
             </a:pPr>
@@ -7523,7 +7546,7 @@
             <a:pPr>
               <a:defRPr sz="1100">
                 <a:solidFill>
-                  <a:srgbClr val="F0F0F5"/>
+                  <a:srgbClr val="3F3F46"/>
                 </a:solidFill>
               </a:defRPr>
             </a:pPr>
@@ -7536,7 +7559,7 @@
             <a:pPr>
               <a:defRPr sz="1300" b="1">
                 <a:solidFill>
-                  <a:srgbClr val="008080"/>
+                  <a:srgbClr val="00695C"/>
                 </a:solidFill>
               </a:defRPr>
             </a:pPr>
@@ -7548,7 +7571,7 @@
             <a:pPr>
               <a:defRPr sz="1100">
                 <a:solidFill>
-                  <a:srgbClr val="F0F0F5"/>
+                  <a:srgbClr val="3F3F46"/>
                 </a:solidFill>
               </a:defRPr>
             </a:pPr>
@@ -7561,7 +7584,7 @@
             <a:pPr>
               <a:defRPr sz="1300" b="1">
                 <a:solidFill>
-                  <a:srgbClr val="008080"/>
+                  <a:srgbClr val="00695C"/>
                 </a:solidFill>
               </a:defRPr>
             </a:pPr>
@@ -7573,7 +7596,7 @@
             <a:pPr>
               <a:defRPr sz="1100">
                 <a:solidFill>
-                  <a:srgbClr val="F0F0F5"/>
+                  <a:srgbClr val="3F3F46"/>
                 </a:solidFill>
               </a:defRPr>
             </a:pPr>
@@ -7598,13 +7621,14 @@
             <a:avLst/>
           </a:prstGeom>
           <a:solidFill>
-            <a:srgbClr val="1C1C1E"/>
+            <a:srgbClr val="FFFFFF"/>
           </a:solidFill>
           <a:ln w="19050">
             <a:solidFill>
               <a:srgbClr val="FFC107"/>
             </a:solidFill>
           </a:ln>
+          <a:effectLst/>
         </p:spPr>
         <p:style>
           <a:lnRef idx="1">
@@ -7653,7 +7677,7 @@
             <a:pPr>
               <a:defRPr sz="1400" b="1">
                 <a:solidFill>
-                  <a:srgbClr val="FFC107"/>
+                  <a:srgbClr val="92400E"/>
                 </a:solidFill>
                 <a:latin typeface="Arial"/>
               </a:defRPr>
@@ -7689,7 +7713,7 @@
             <a:pPr>
               <a:defRPr sz="1600" b="1" i="1">
                 <a:solidFill>
-                  <a:srgbClr val="FFC107"/>
+                  <a:srgbClr val="92400E"/>
                 </a:solidFill>
               </a:defRPr>
             </a:pPr>
@@ -7703,7 +7727,7 @@
             <a:pPr>
               <a:defRPr sz="1200">
                 <a:solidFill>
-                  <a:srgbClr val="FFFFFF"/>
+                  <a:srgbClr val="18181B"/>
                 </a:solidFill>
               </a:defRPr>
             </a:pPr>
@@ -7724,7 +7748,7 @@
             <a:pPr>
               <a:defRPr sz="1100" b="1">
                 <a:solidFill>
-                  <a:srgbClr val="008080"/>
+                  <a:srgbClr val="00695C"/>
                 </a:solidFill>
               </a:defRPr>
             </a:pPr>

</xml_diff>

<commit_message>
Regenerate Protiti_Pitch_Deck.pptx from the corrected generator
Co-Authored-By: Claude Opus 5.5 <noreply@anthropic.com>
</commit_message>
<xml_diff>
--- a/pitch_materials/Protiti_Pitch_Deck.pptx
+++ b/pitch_materials/Protiti_Pitch_Deck.pptx
@@ -3256,7 +3256,7 @@
               </a:defRPr>
             </a:pPr>
             <a:r>
-              <a:t>A Trauma-Informed Digital Evidence Vault, Legal Automator (Cyber Protection Act 2026), and Offline Emergency SOS Framework for Women in Bangladesh.</a:t>
+              <a:t>A research prototype: an encrypted evidence vault, a General Diary (GD) draft for manual filing, and an SMS SOS, for women in Bangladesh. Not for real use until reviewed by a security expert and a field partner.</a:t>
             </a:r>
           </a:p>
           <a:p>
@@ -3463,7 +3463,7 @@
               </a:defRPr>
             </a:pPr>
             <a:r>
-              <a:t>   Legal Advisor &amp; Statutory Compliance (CPA 2026)</a:t>
+              <a:t>   Legal Advisor &amp; Statutory Compliance (cyber law / Evidence Act)</a:t>
             </a:r>
           </a:p>
           <a:p>
@@ -3524,11 +3524,11 @@
               </a:defRPr>
             </a:pPr>
             <a:r>
-              <a:t>THE CRITICAL REALITY:</a:t>
+              <a:t>THE REALITY:</a:t>
             </a:r>
             <a:br/>
             <a:r>
-              <a:t>64% of Bangladeshi women face online harassment; 80%+ cases go unreported due to evidence destruction and legal intimidation.</a:t>
+              <a:t>About 64% of the 359 women who completed a 2022 ActionAid Bangladesh online survey said they had faced online violence (Prothom Alo, 28 Nov 2022; not a national sample).</a:t>
             </a:r>
           </a:p>
         </p:txBody>
@@ -3783,7 +3783,7 @@
               </a:defRPr>
             </a:pPr>
             <a:r>
-              <a:t>Out of immediate panic or fear of family discovery, 80%+ of victims delete chat logs and block abusers, irreversibly erasing digital proof required by police and prosecutors.</a:t>
+              <a:t>Out of fear, or worry that family will find out, many victims delete chats and block abusers, destroying proof before police can act.</a:t>
             </a:r>
           </a:p>
           <a:p>
@@ -3796,7 +3796,7 @@
               </a:defRPr>
             </a:pPr>
             <a:r>
-              <a:t>Impact: Without bitwise evidence, law enforcement cannot file an FIR under CrPC Sec 154.</a:t>
+              <a:t>Impact: With no evidence left, police have little to act on.</a:t>
             </a:r>
           </a:p>
         </p:txBody>
@@ -3913,7 +3913,7 @@
               </a:defRPr>
             </a:pPr>
             <a:r>
-              <a:t>The Cyber Security Act has been repealed by the Cyber Protection Act 2026. General Diary (GD) drafting demands specific statutory mapping that ordinary survivors cannot navigate alone.</a:t>
+              <a:t>Cyber law in Bangladesh has changed more than once since 2023. Drafting a General Diary (GD) is bewildering for traumatised victims.</a:t>
             </a:r>
           </a:p>
           <a:p>
@@ -3926,7 +3926,7 @@
               </a:defRPr>
             </a:pPr>
             <a:r>
-              <a:t>Impact: Duty officers reject handwritten, unstructured victim complaints at local Thanas.</a:t>
+              <a:t>Impact: Unstructured complaints are hard for duty officers to act on.</a:t>
             </a:r>
           </a:p>
         </p:txBody>
@@ -4043,7 +4043,7 @@
               </a:defRPr>
             </a:pPr>
             <a:r>
-              <a:t>Simple screenshots are easily dismissed in court. Defense lawyers routinely challenge them for lack of metadata, timestamps, URL origins, or Evidence Act Section 65B certificates.</a:t>
+              <a:t>Screenshots without links, dates and account names are easy to doubt. The Evidence (Amendment) Act 2022 allows digital records, with forensic examination if authenticity is disputed.</a:t>
             </a:r>
           </a:p>
           <a:p>
@@ -4056,7 +4056,7 @@
               </a:defRPr>
             </a:pPr>
             <a:r>
-              <a:t>Impact: Forensic admissibility fails before the Divisional Cyber Tribunals.</a:t>
+              <a:t>Impact: Poorly kept evidence can weaken a genuine complaint.</a:t>
             </a:r>
           </a:p>
         </p:txBody>
@@ -4441,15 +4441,15 @@
               </a:defRPr>
             </a:pPr>
             <a:r>
-              <a:t>• AES-256 / SQLCipher local encryption with zero cloud exposure of sensitive media.</a:t>
+              <a:t>• On-device only: evidence is encrypted on the phone (SQLCipher, AES-256). Nothing is uploaded.</a:t>
             </a:r>
             <a:br/>
             <a:r>
-              <a:t>• Duress PIN (Decoy Vault): Entering 9999 loads benign notes/recipes to safely bypass physical coercion.</a:t>
+              <a:t>• Duress PIN (Decoy Vault): a second PIN, chosen by the user, opens a separate decoy vault.</a:t>
             </a:r>
             <a:br/>
             <a:r>
-              <a:t>• Stealth Calculator Disguise: Masked as functional arithmetic utility.</a:t>
+              <a:t>• Calculator Disguise: the app opens as a working calculator.</a:t>
             </a:r>
           </a:p>
         </p:txBody>
@@ -4531,7 +4531,7 @@
               </a:defRPr>
             </a:pPr>
             <a:r>
-              <a:t>📝 Automated e-GD Generator</a:t>
+              <a:t>📝 GD Draft</a:t>
             </a:r>
           </a:p>
         </p:txBody>
@@ -4566,15 +4566,15 @@
               </a:defRPr>
             </a:pPr>
             <a:r>
-              <a:t>• Translates traumatic experiences into standard Bangladesh Police e-GD schema (gd.police.gov.bd).</a:t>
+              <a:t>• Guided form: short questions turn the survivor's account and evidence list into a GD draft.</a:t>
             </a:r>
             <a:br/>
             <a:r>
-              <a:t>• Direct Section mapping to Cyber Protection Act 2026 &amp; Pornography Control Act 2012.</a:t>
+              <a:t>• Manual filing: no e-GD integration and no automatic law mapping. A lawyer or PCSW officer should check the draft.</a:t>
             </a:r>
             <a:br/>
             <a:r>
-              <a:t>• Generates bilingual (Bengali/English) printable PDF with QR verification.</a:t>
+              <a:t>• Printable PDF. Bangla text in the PDF is a known bug.</a:t>
             </a:r>
           </a:p>
         </p:txBody>
@@ -4699,7 +4699,7 @@
             </a:r>
             <a:br/>
             <a:r>
-              <a:t>• One-touch speed dialing for National Emergency 999 and Police Cyber Support for Women (PCSW).</a:t>
+              <a:t>• One-tap dialing for 999, 109 and Police Cyber Support for Women (PCSW).</a:t>
             </a:r>
           </a:p>
         </p:txBody>
@@ -4781,7 +4781,7 @@
               </a:defRPr>
             </a:pPr>
             <a:r>
-              <a:t>🤝 Support Bridge Network</a:t>
+              <a:t>🤝 Support Directory</a:t>
             </a:r>
           </a:p>
         </p:txBody>
@@ -4816,15 +4816,15 @@
               </a:defRPr>
             </a:pPr>
             <a:r>
-              <a:t>• Direct institutional escalation to BLAST (2,500 panel lawyers) &amp; BNWLA for pro-bono representation.</a:t>
+              <a:t>• Legal aid (proposed): referral routes to BLAST and BNWLA are proposed. Neither has agreed.</a:t>
             </a:r>
             <a:br/>
             <a:r>
-              <a:t>• Integrated crisis counseling directory (Kaan Pete Roi, Moner Janala).</a:t>
+              <a:t>• Crisis counselling directory (Kaan Pete Roi, Moner Janala).</a:t>
             </a:r>
             <a:br/>
             <a:r>
-              <a:t>• Confidential triage by vetted female cyber crime officers.</a:t>
+              <a:t>• PCSW contact details (to verify with PCSW).</a:t>
             </a:r>
           </a:p>
         </p:txBody>
@@ -4962,7 +4962,7 @@
               </a:defRPr>
             </a:pPr>
             <a:r>
-              <a:t>Guided step-by-step pipeline transforming chaotic abuse into courtroom-admissible evidence.</a:t>
+              <a:t>A trauma-informed path from harassment to an organised GD draft.</a:t>
             </a:r>
           </a:p>
         </p:txBody>
@@ -5079,7 +5079,7 @@
               </a:defRPr>
             </a:pPr>
             <a:r>
-              <a:t>Survivor captures screenshot, audio voice note, URL, or harassing chat before blocking abuser.</a:t>
+              <a:t>Survivor saves a screenshot, photo, voice note or written note before blocking the abuser.</a:t>
             </a:r>
           </a:p>
         </p:txBody>
@@ -5196,7 +5196,7 @@
               </a:defRPr>
             </a:pPr>
             <a:r>
-              <a:t>Protiti extracts RFC 3161 timestamps, EXIF metadata, and generates bitwise SHA-256 forensic hash.</a:t>
+              <a:t>Protiti records the phone's date and time and a SHA-256 file hash. This is not a forensic timestamp.</a:t>
             </a:r>
           </a:p>
         </p:txBody>
@@ -5430,7 +5430,7 @@
               </a:defRPr>
             </a:pPr>
             <a:r>
-              <a:t>Engine auto-maps facts to CPA 2026 sections, generating DMP-standard General Diary (e-GD payload).</a:t>
+              <a:t>The app lays the facts out as a General Diary draft PDF. It does not pick legal sections.</a:t>
             </a:r>
           </a:p>
         </p:txBody>
@@ -5547,7 +5547,7 @@
               </a:defRPr>
             </a:pPr>
             <a:r>
-              <a:t>Survivor submits directly to Thana / PCSW online, or dispatches securely to BLAST/BNWLA legal counsel.</a:t>
+              <a:t>Survivor files the draft at the thana or shares it with a lawyer or PCSW.</a:t>
             </a:r>
           </a:p>
         </p:txBody>
@@ -5668,7 +5668,7 @@
             </a:r>
             <a:br/>
             <a:r>
-              <a:t>AFTER: Untouched encrypted vault → Bitwise SHA-256 verification → Evidence Act Sec 65B certified GD → Rapid police action.</a:t>
+              <a:t>AFTER: Encrypted vault on the phone → Organised evidence list → GD draft ready to file → A clearer case for police.</a:t>
             </a:r>
           </a:p>
         </p:txBody>
@@ -5793,7 +5793,7 @@
               </a:defRPr>
             </a:pPr>
             <a:r>
-              <a:t>Technology &amp; Security: Built for Real-World Survival</a:t>
+              <a:t>Technology &amp; Security: What the Prototype Does</a:t>
             </a:r>
           </a:p>
           <a:p>
@@ -5806,7 +5806,7 @@
               </a:defRPr>
             </a:pPr>
             <a:r>
-              <a:t>Engineered to withstand physical coercion, rural network blackouts, and courtroom scrutiny.</a:t>
+              <a:t>Not yet reviewed by a security expert or tested on a real phone.</a:t>
             </a:r>
           </a:p>
         </p:txBody>
@@ -5888,7 +5888,7 @@
               </a:defRPr>
             </a:pPr>
             <a:r>
-              <a:t>🔐 Dual-Vault &amp; Duress PIN</a:t>
+              <a:t>🔐 Encrypted Vault &amp; Duress PIN</a:t>
             </a:r>
           </a:p>
         </p:txBody>
@@ -5923,7 +5923,7 @@
               </a:defRPr>
             </a:pPr>
             <a:r>
-              <a:t>Hardware-backed Keystore/Keychain encryption (SQLCipher AES-256). Entering Master PIN ('1234') unlocks forensic records; entering Duress PIN ('9999') loads an innocent personal diary.</a:t>
+              <a:t>SQLCipher AES-256 with keys in Android Keystore / iOS Keychain. The real PIN (6 or more digits, set at first launch) opens the vault; a separate duress PIN opens a decoy vault with its own file and key. No default PINs.</a:t>
             </a:r>
           </a:p>
         </p:txBody>
@@ -6005,7 +6005,7 @@
               </a:defRPr>
             </a:pPr>
             <a:r>
-              <a:t>📲 Launcher Stealth Disguise</a:t>
+              <a:t>📲 Calculator Disguise</a:t>
             </a:r>
           </a:p>
         </p:txBody>
@@ -6040,7 +6040,7 @@
               </a:defRPr>
             </a:pPr>
             <a:r>
-              <a:t>Fully functioning 'Smart Calc' persona. Android PackageManager activity-alias toggling hides forensic markers from device inspectors. Face-down quick-exit gesture wipes active RAM.</a:t>
+              <a:t>The app opens as a working calculator; typing your PIN then = opens the vault. The home-screen icon is not disguised yet. A wipe code that the user chooses triggers the vault wipe.</a:t>
             </a:r>
           </a:p>
         </p:txBody>
@@ -6157,7 +6157,7 @@
               </a:defRPr>
             </a:pPr>
             <a:r>
-              <a:t>Lightweight GPS extraction (&lt;160 chars) transmitted over native cellular SMS without dependency on mobile data/Wi-Fi. Direct USSD &amp; hotline fallbacks for rural divisional settings.</a:t>
+              <a:t>Short GPS message (&lt;160 chars) sent over cellular SMS, without mobile data or Wi-Fi. It still needs signal and SMS credit. One tap dials 999, 109 or the PCSW hotline.</a:t>
             </a:r>
           </a:p>
         </p:txBody>
@@ -6239,7 +6239,7 @@
               </a:defRPr>
             </a:pPr>
             <a:r>
-              <a:t>⚖️ Evidence Act Sec 65B Engine</a:t>
+              <a:t>⚖️ Evidence Notes</a:t>
             </a:r>
           </a:p>
         </p:txBody>
@@ -6274,7 +6274,7 @@
               </a:defRPr>
             </a:pPr>
             <a:r>
-              <a:t>SHA-256 cryptographic hashing (NIST FIPS 180-4) with automated Certificate of Electronic Authenticity adhering to the Evidence (Amendment) Act 2022 and CID forensic lab protocols.</a:t>
+              <a:t>A SHA-256 hash is recorded for each stored file (today of the encrypted file, not the original). Times come from the phone clock. No certificate of authenticity; admissibility needs review by counsel.</a:t>
             </a:r>
           </a:p>
         </p:txBody>
@@ -6399,7 +6399,7 @@
               </a:defRPr>
             </a:pPr>
             <a:r>
-              <a:t>Target Community &amp; Measurable Ecosystem Impact</a:t>
+              <a:t>Target Community &amp; Goals</a:t>
             </a:r>
           </a:p>
           <a:p>
@@ -6566,7 +6566,7 @@
               </a:defRPr>
             </a:pPr>
             <a:r>
-              <a:t>   Rural and peri-urban youth accessing digital safety toolkits through BRAC community networks and Union Digital Centres (UDCs).</a:t>
+              <a:t>   Rural and peri-urban youth, through community networks and Union Digital Centres (UDCs) (proposed; no partner agreed).</a:t>
             </a:r>
             <a:br/>
           </a:p>
@@ -6579,7 +6579,7 @@
               </a:defRPr>
             </a:pPr>
             <a:r>
-              <a:t>• Institutional Stakeholders: </a:t>
+              <a:t>• Proposed Partners: </a:t>
             </a:r>
           </a:p>
           <a:p>
@@ -6591,7 +6591,7 @@
               </a:defRPr>
             </a:pPr>
             <a:r>
-              <a:t>   Police Cyber Support for Women (PCSW), Thana cyber desks, and pro-bono panels at BLAST and BNWLA.</a:t>
+              <a:t>   Police Cyber Support for Women (PCSW), Thana cyber desks, and legal aid groups such as BLAST and BNWLA. None has agreed yet.</a:t>
             </a:r>
             <a:br/>
           </a:p>
@@ -6674,7 +6674,7 @@
               </a:defRPr>
             </a:pPr>
             <a:r>
-              <a:t>8-MONTH QUANTITATIVE IMPACT TARGETS</a:t>
+              <a:t>8-MONTH GOALS (NOT YET MEASURED)</a:t>
             </a:r>
           </a:p>
         </p:txBody>
@@ -6709,7 +6709,7 @@
               </a:defRPr>
             </a:pPr>
             <a:r>
-              <a:t>✔ 80%+ Reduction in Evidence Destruction</a:t>
+              <a:t>✔ Less Evidence Destroyed</a:t>
             </a:r>
           </a:p>
           <a:p>
@@ -6721,7 +6721,7 @@
               </a:defRPr>
             </a:pPr>
             <a:r>
-              <a:t>   Survivors preserve bitwise intact records instead of deleting traumatic chats.</a:t>
+              <a:t>   Survivors keep records instead of deleting them in panic. No baseline yet.</a:t>
             </a:r>
           </a:p>
           <a:p>
@@ -6757,7 +6757,7 @@
               </a:defRPr>
             </a:pPr>
             <a:r>
-              <a:t>✔ 3x Increase in Admissible e-GDs Filed</a:t>
+              <a:t>✔ Better GD Drafts</a:t>
             </a:r>
           </a:p>
           <a:p>
@@ -6769,7 +6769,7 @@
               </a:defRPr>
             </a:pPr>
             <a:r>
-              <a:t>   Eliminating bureaucratic rejection at local police stations via standardized schema.</a:t>
+              <a:t>   More complete drafts that a duty officer can act on. No baseline yet.</a:t>
             </a:r>
           </a:p>
           <a:p>
@@ -6781,7 +6781,7 @@
               </a:defRPr>
             </a:pPr>
             <a:r>
-              <a:t>✔ 100% Pro-Bono Legal Escalation</a:t>
+              <a:t>✔ Legal Aid Referral (proposed)</a:t>
             </a:r>
           </a:p>
           <a:p>
@@ -6793,7 +6793,7 @@
               </a:defRPr>
             </a:pPr>
             <a:r>
-              <a:t>   Immediate referral to BLAST's 2,500 panel lawyers for indigent victims.</a:t>
+              <a:t>   Referral routes to legal aid groups such as BLAST, once one agrees.</a:t>
             </a:r>
           </a:p>
           <a:p>
@@ -6805,7 +6805,7 @@
               </a:defRPr>
             </a:pPr>
             <a:r>
-              <a:t>✔ 24/7 Offline Emergency Redundancy</a:t>
+              <a:t>✔ Offline SMS SOS</a:t>
             </a:r>
           </a:p>
           <a:p>
@@ -6817,7 +6817,7 @@
               </a:defRPr>
             </a:pPr>
             <a:r>
-              <a:t>   SMS-based coordinates ensure rural safety even in zero-data mobile blackouts.</a:t>
+              <a:t>   SMS-based location works without mobile data, if there is signal and SMS credit.</a:t>
             </a:r>
           </a:p>
         </p:txBody>
@@ -7084,7 +7084,7 @@
               </a:defRPr>
             </a:pPr>
             <a:r>
-              <a:t>   Finalize on-device SQLCipher vault, Duress PIN, e-GD schema. Conduct BLAST forensic hash validation. Attend Innovation Bootcamp.</a:t>
+              <a:t>   Finalize on-device SQLCipher vault, Duress PIN, GD draft template. Ask a legal aid group (for example BLAST; nothing agreed) to review the evidence format. Attend Innovation Bootcamp.</a:t>
             </a:r>
             <a:br/>
           </a:p>
@@ -7134,7 +7134,7 @@
               </a:defRPr>
             </a:pPr>
             <a:r>
-              <a:t>   National showcase with Cyber Police Centre &amp; UNDP presenting audited Dhaka Pilot results plus the National 8-Division Expansion Roadmap. Open-source the e-GD legal framework. Transition to alumni network.</a:t>
+              <a:t>   National showcase with Cyber Police Centre &amp; UNDP presenting audited Dhaka Pilot results plus the National 8-Division Expansion Roadmap. Open-source the GD draft template. Transition to alumni network.</a:t>
             </a:r>
             <a:br/>
           </a:p>
@@ -7539,7 +7539,7 @@
               </a:defRPr>
             </a:pPr>
             <a:r>
-              <a:t>✔ Institutional Handover</a:t>
+              <a:t>✔ Proposed Handover</a:t>
             </a:r>
           </a:p>
           <a:p>
@@ -7551,7 +7551,7 @@
               </a:defRPr>
             </a:pPr>
             <a:r>
-              <a:t>Engineered for long-term stewardship by Police Cyber Support for Women (PCSW) and the ICT Division's Cyber Help initiatives.</a:t>
+              <a:t>Seek a long-term owner such as PCSW, a legal aid NGO or the ICT Division's Cyber Help initiatives. None has agreed yet.</a:t>
             </a:r>
           </a:p>
           <a:p>
@@ -7564,7 +7564,7 @@
               </a:defRPr>
             </a:pPr>
             <a:r>
-              <a:t>✔ Open-Source Legal Schema</a:t>
+              <a:t>✔ Open-Source Template</a:t>
             </a:r>
           </a:p>
           <a:p>
@@ -7576,7 +7576,7 @@
               </a:defRPr>
             </a:pPr>
             <a:r>
-              <a:t>The e-GD mapping engine is released as open-source civic tech, allowing civic organizations to update legal sections as laws evolve.</a:t>
+              <a:t>Publish the GD draft template, after counsel review, so legal aid clinics can keep it up to date.</a:t>
             </a:r>
           </a:p>
           <a:p>

</xml_diff>